<commit_message>
Evento 17/08: cronograma travado, deck versao-evento e demo Meridiano
- Cronograma §2f de trás pra frente (convites amanhã; ensaios remotos
  qui/sex com Pedro, que chega dia 17; teste técnico 16h; follow-up 48h)
- Deck regenerado: capa "Encontros Direito & IA - 1ª edição · 17/08/2026"
  + guia de ritmo nas notas do apresentador (palestra 20-25 min, demo
  entre slides 9 e 10)
- Nova demo da palestra: Análise ABBA de escritório fictício (Meridiano
  Advogados, 4 lâminas com notas) — formato do Mapa de Vazamento com
  faixa, premissas com fonte e o convite "feito de fora"

Co-Authored-By: Claude Fable 5 <noreply@anthropic.com>
Claude-Session: https://claude.ai/code/session_01MuoVL7ShCtU9xagHU9oXkT
</commit_message>
<xml_diff>
--- a/08-materiais/modelos/palestra-direito-e-ia-deck.pptx
+++ b/08-materiais/modelos/palestra-direito-e-ia-deck.pptx
@@ -513,7 +513,7 @@
           <a:p>
             <a:r>
               <a:rPr lang="en-US" dirty="0"/>
-              <a:t>Obrigado pelo convite. Nós trabalhamos instalando capacidade de IA em empresas — e hoje queremos conversar sobre o que essa onda significa especificamente para quem advoga. Prometemos duas coisas: nenhum hype, e pelo menos uma ideia que vocês possam aplicar segunda-feira de manhã.</a:t>
+              <a:t>[RITMO ~1 min — capa no telão enquanto o anfitrião abre] Obrigado pelo convite. Nós trabalhamos instalando capacidade de IA em empresas — e hoje queremos conversar sobre o que essa onda significa especificamente para quem advoga. Prometemos duas coisas: nenhum hype, e pelo menos uma ideia que vocês possam aplicar segunda-feira de manhã.</a:t>
             </a:r>
             <a:endParaRPr lang="en-US" dirty="0"/>
           </a:p>
@@ -601,7 +601,7 @@
           <a:p>
             <a:r>
               <a:rPr lang="en-US" dirty="0"/>
-              <a:t>Tudo que o Código de Ética exige de vocês pode — e deve — ser exigido da arquitetura de IA que entrar aqui. Esses quatro princípios são o nosso jeito de construir, e são também um checklist que vocês podem usar amanhã para avaliar qualquer fornecedor. Anotem e usem — de graça.</a:t>
+              <a:t>[RITMO ~1,5 min] Tudo que o Código de Ética exige de vocês pode — e deve — ser exigido da arquitetura de IA que entrar aqui. Esses quatro princípios são o nosso jeito de construir, e são também um checklist que vocês podem usar amanhã para avaliar qualquer fornecedor. Anotem e usem — de graça.</a:t>
             </a:r>
             <a:endParaRPr lang="en-US" dirty="0"/>
           </a:p>
@@ -689,7 +689,7 @@
           <a:p>
             <a:r>
               <a:rPr lang="en-US" dirty="0"/>
-              <a:t>Trinta segundos sobre nós, prometo. Fazemos as duas coisas que não dá para fazer de dentro: construção em escala e prova de terceiro — o número combinado antes, medido depois, validado por gente de vocês. E começamos sempre da mesma forma: provando o método antes de custar qualquer coisa.</a:t>
+              <a:t>[RITMO ~1 min — os 30 segundos prometidos] Trinta segundos sobre nós, prometo. Fazemos as duas coisas que não dá para fazer de dentro: construção em escala e prova de terceiro — o número combinado antes, medido depois, validado por gente de vocês. E começamos sempre da mesma forma: provando o método antes de custar qualquer coisa.</a:t>
             </a:r>
             <a:endParaRPr lang="en-US" dirty="0"/>
           </a:p>
@@ -777,7 +777,7 @@
           <a:p>
             <a:r>
               <a:rPr lang="en-US" dirty="0"/>
-              <a:t>A terceira pergunta da Bússola é a mais importante — e num escritório a resposta é bonita: julgamento, estratégia, ética, a relação de confiança com o cliente. A IA bem usada devolve tempo exatamente para isso. Quem quiser ver o método funcionando no próprio escritório: nós preparamos uma análise por informação pública e apresentamos em 45 minutos — sem custo, sem compromisso. É a nossa degustação, e é também o nosso teste: se ela não gerar uma boa conversa, vocês não perderam nada além de um café. Obrigado.</a:t>
+              <a:t>[RITMO ~1,5 min — fecho e convite; depois o Q&amp;A moderado] A terceira pergunta da Bússola é a mais importante — e num escritório a resposta é bonita: julgamento, estratégia, ética, a relação de confiança com o cliente. A IA bem usada devolve tempo exatamente para isso. Quem quiser ver o método funcionando no próprio escritório: nós preparamos uma análise por informação pública e apresentamos em 45 minutos — sem custo, sem compromisso. É a nossa degustação, e é também o nosso teste: se ela não gerar uma boa conversa, vocês não perderam nada além de um café. Obrigado.</a:t>
             </a:r>
             <a:endParaRPr lang="en-US" dirty="0"/>
           </a:p>
@@ -865,7 +865,7 @@
           <a:p>
             <a:r>
               <a:rPr lang="en-US" dirty="0"/>
-              <a:t>Três fatos do mundo real, nenhum de fornecedor. A pergunta desta noite não é SE a IA entra na advocacia — ela já entrou. A pergunta é quem está decidindo COMO.</a:t>
+              <a:t>[RITMO ~2 min — rápido] Três fatos do mundo real, nenhum de fornecedor. A pergunta desta noite não é SE a IA entra na advocacia — ela já entrou. A pergunta é quem está decidindo COMO.</a:t>
             </a:r>
             <a:endParaRPr lang="en-US" dirty="0"/>
           </a:p>
@@ -953,7 +953,7 @@
           <a:p>
             <a:r>
               <a:rPr lang="en-US" dirty="0"/>
-              <a:t>Esse é o dado que muda a conversa. A ferramenta mais bem-sucedida do país não foi feita para vocês — foi feita para os clientes de vocês. A resposta estratégica não é comprar uma ferramenta parecida; é decidir o que o escritório passa a ser quando o volume deixa de pagar a conta.</a:t>
+              <a:t>[RITMO ~1,5 min — rápido] Esse é o dado que muda a conversa. A ferramenta mais bem-sucedida do país não foi feita para vocês — foi feita para os clientes de vocês. A resposta estratégica não é comprar uma ferramenta parecida; é decidir o que o escritório passa a ser quando o volume deixa de pagar a conta.</a:t>
             </a:r>
             <a:endParaRPr lang="en-US" dirty="0"/>
           </a:p>
@@ -1041,7 +1041,7 @@
           <a:p>
             <a:r>
               <a:rPr lang="en-US" dirty="0"/>
-              <a:t>Em quase toda banca existe hoje uma política de IA de papel e uma prática de IA real — e elas não se conhecem. Ninguém aqui autorizou dado de cliente em ferramenta gratuita; ele está lá mesmo assim. Isso não se resolve com proibição — proibição só empurra para o celular pessoal. Se resolve com governança que funciona.</a:t>
+              <a:t>[RITMO ~2,5 min — desacelerar: é onde a sala se reconhece] Em quase toda banca existe hoje uma política de IA de papel e uma prática de IA real — e elas não se conhecem. Ninguém aqui autorizou dado de cliente em ferramenta gratuita; ele está lá mesmo assim. Isso não se resolve com proibição — proibição só empurra para o celular pessoal. Se resolve com governança que funciona.</a:t>
             </a:r>
             <a:endParaRPr lang="en-US" dirty="0"/>
           </a:p>
@@ -1129,7 +1129,7 @@
           <a:p>
             <a:r>
               <a:rPr lang="en-US" dirty="0"/>
-              <a:t>Quem espera 'a regulamentação sair' para se organizar está lendo o calendário errado: as obrigações de sigilo e de dado pessoal já existem, a OAB já recomendou, o CNJ já normatizou o lado do Judiciário. O custo de se organizar agora é planejamento; depois, é resposta a incidente.</a:t>
+              <a:t>[RITMO ~2 min] Quem espera 'a regulamentação sair' para se organizar está lendo o calendário errado: as obrigações de sigilo e de dado pessoal já existem, a OAB já recomendou, o CNJ já normatizou o lado do Judiciário. O custo de se organizar agora é planejamento; depois, é resposta a incidente.</a:t>
             </a:r>
             <a:endParaRPr lang="en-US" dirty="0"/>
           </a:p>
@@ -1217,7 +1217,7 @@
           <a:p>
             <a:r>
               <a:rPr lang="en-US" dirty="0"/>
-              <a:t>Nós vimos esses quatro filmes em outros setores, e o roteiro no jurídico é idêntico. Nenhum deles é culpa da ferramenta. Todos são a parte organizacional que ninguém vende em caixinha.</a:t>
+              <a:t>[RITMO ~2,5 min] Nós vimos esses quatro filmes em outros setores, e o roteiro no jurídico é idêntico. Nenhum deles é culpa da ferramenta. Todos são a parte organizacional que ninguém vende em caixinha.</a:t>
             </a:r>
             <a:endParaRPr lang="en-US" dirty="0"/>
           </a:p>
@@ -1305,7 +1305,7 @@
           <a:p>
             <a:r>
               <a:rPr lang="en-US" dirty="0"/>
-              <a:t>Essa é a conversa honesta que os vendedores de ferramenta pulam. Para banca que fatura por hora, IA mal desenhada é ameaça de receita. Bem desenhada, ela muda o que o sócio consegue supervisionar e o que o cliente percebe — e esses dois números pagam a conta. Mas isso é decisão de desenho do modelo, não uma licença de software.</a:t>
+              <a:t>[RITMO ~2 min] Essa é a conversa honesta que os vendedores de ferramenta pulam. Para banca que fatura por hora, IA mal desenhada é ameaça de receita. Bem desenhada, ela muda o que o sócio consegue supervisionar e o que o cliente percebe — e esses dois números pagam a conta. Mas isso é decisão de desenho do modelo, não uma licença de software.</a:t>
             </a:r>
             <a:endParaRPr lang="en-US" dirty="0"/>
           </a:p>
@@ -1393,7 +1393,7 @@
           <a:p>
             <a:r>
               <a:rPr lang="en-US" dirty="0"/>
-              <a:t>Reparem no padrão: em todos os casos que funcionam, a IA está DENTRO do fluxo de quem trabalha, com revisão humana no ponto certo — e em todos os que fracassam, ela é uma plataforma separada que alguém deveria visitar. A adoção é desenho, não boa vontade.</a:t>
+              <a:t>[RITMO ~2 min] Reparem no padrão: em todos os casos que funcionam, a IA está DENTRO do fluxo de quem trabalha, com revisão humana no ponto certo — e em todos os que fracassam, ela é uma plataforma separada que alguém deveria visitar. A adoção é desenho, não boa vontade.</a:t>
             </a:r>
             <a:endParaRPr lang="en-US" dirty="0"/>
           </a:p>
@@ -1481,7 +1481,7 @@
           <a:p>
             <a:r>
               <a:rPr lang="en-US" dirty="0"/>
-              <a:t>Se vocês levarem uma única frase desta noite, que seja essa. Antes de qualquer piloto, qualquer ferramenta, qualquer comitê: qual número, em quanto tempo, medido por quem? Quem faz essa pergunta primeiro transforma; quem não faz, testa ferramentas para sempre.</a:t>
+              <a:t>[RITMO ~2 min → AQUI ENTRA A DEMONSTRAÇÃO AO VIVO (5–7 min): a Análise ABBA do escritório fictício] Se vocês levarem uma única frase desta noite, que seja essa. Antes de qualquer piloto, qualquer ferramenta, qualquer comitê: qual número, em quanto tempo, medido por quem? Quem faz essa pergunta primeiro transforma; quem não faz, testa ferramentas para sempre.</a:t>
             </a:r>
             <a:endParaRPr lang="en-US" dirty="0"/>
           </a:p>
@@ -1863,23 +1863,23 @@
         <p:spPr>
           <a:xfrm>
             <a:off x="822960" y="1371600"/>
-            <a:ext cx="5486400" cy="320040"/>
-          </a:xfrm>
-          <a:prstGeom prst="rect">
-            <a:avLst/>
-          </a:prstGeom>
-          <a:noFill/>
-          <a:ln/>
-        </p:spPr>
-        <p:txBody>
-          <a:bodyPr wrap="square" lIns="0" tIns="0" rIns="0" bIns="0" rtlCol="0" anchor="ctr"/>
-          <a:lstStyle/>
-          <a:p>
-            <a:pPr indent="0" marL="0">
-              <a:buNone/>
-            </a:pPr>
-            <a:r>
-              <a:rPr lang="en-US" sz="1300" b="1" spc="600" kern="0" dirty="0">
+            <a:ext cx="8229600" cy="320040"/>
+          </a:xfrm>
+          <a:prstGeom prst="rect">
+            <a:avLst/>
+          </a:prstGeom>
+          <a:noFill/>
+          <a:ln/>
+        </p:spPr>
+        <p:txBody>
+          <a:bodyPr wrap="square" lIns="0" tIns="0" rIns="0" bIns="0" rtlCol="0" anchor="ctr"/>
+          <a:lstStyle/>
+          <a:p>
+            <a:pPr indent="0" marL="0">
+              <a:buNone/>
+            </a:pPr>
+            <a:r>
+              <a:rPr lang="en-US" sz="1300" b="1" spc="500" kern="0" dirty="0">
                 <a:solidFill>
                   <a:srgbClr val="C2A35B"/>
                 </a:solidFill>
@@ -1887,7 +1887,7 @@
                 <a:ea typeface="Calibri" pitchFamily="34" charset="-122"/>
                 <a:cs typeface="Calibri" pitchFamily="34" charset="-120"/>
               </a:rPr>
-              <a:t>PALESTRA</a:t>
+              <a:t>ENCONTROS DIREITO &amp; IA — 1ª EDIÇÃO</a:t>
             </a:r>
             <a:endParaRPr lang="en-US" sz="1300" dirty="0"/>
           </a:p>
@@ -2004,7 +2004,7 @@
                 <a:ea typeface="Calibri" pitchFamily="34" charset="-122"/>
                 <a:cs typeface="Calibri" pitchFamily="34" charset="-120"/>
               </a:rPr>
-              <a:t>{{NOME DO ESCRITÓRIO}}  ·  Brasília  ·  {{DATA}}</a:t>
+              <a:t>{{NOME DO ESCRITÓRIO}}  ·  Brasília  ·  segunda-feira, 17/08/2026</a:t>
             </a:r>
             <a:endParaRPr lang="en-US" sz="1500" dirty="0"/>
           </a:p>

</xml_diff>